<commit_message>
docs: add verified Kiro pricing-history narrative + hooks accuracy
From the adversarial /deep-research report (high-confidence, 3-0 verified):
- README/youth doc: tell the Aug 2025 pricing-bug -> apology+refunds ->
  Sep 15 four-tier -> later five-tier (Pro Max) story, with sources.
- README hooks: a hook action is an agent prompt OR a shell command;
  shell hooks don't consume credits. Softened the trigger-event wording
  (a specific expanded event list was refuted in verification).
- README: note model choice affects credit burn (Sonnet-only ~1.3x Auto).
- Deck slide 8: compact pricing-drama note. Regenerated pptx.

Co-Authored-By: Claude Opus 4.8 (1M context) <noreply@anthropic.com>
</commit_message>
<xml_diff>
--- a/Kiro_IDE_Orchestrator_2026_Jugend.pptx
+++ b/Kiro_IDE_Orchestrator_2026_Jugend.pptx
@@ -14861,8 +14861,8 @@
         </p:nvSpPr>
         <p:spPr>
           <a:xfrm>
-            <a:off x="640080" y="5989320"/>
-            <a:ext cx="10881360" cy="457200"/>
+            <a:off x="640080" y="5797296"/>
+            <a:ext cx="10881360" cy="822960"/>
           </a:xfrm>
           <a:prstGeom prst="rect">
             <a:avLst/>
@@ -14877,17 +14877,17 @@
           <a:p>
             <a:pPr algn="l">
               <a:lnSpc>
-                <a:spcPct val="100000"/>
-              </a:lnSpc>
-              <a:spcBef>
-                <a:spcPts val="0"/>
-              </a:spcBef>
-              <a:spcAft>
-                <a:spcPts val="600"/>
-              </a:spcAft>
-            </a:pPr>
-            <a:r>
-              <a:rPr sz="1300" b="1" i="0">
+                <a:spcPct val="105000"/>
+              </a:lnSpc>
+              <a:spcBef>
+                <a:spcPts val="0"/>
+              </a:spcBef>
+              <a:spcAft>
+                <a:spcPts val="400"/>
+              </a:spcAft>
+            </a:pPr>
+            <a:r>
+              <a:rPr sz="1250" b="1" i="0">
                 <a:solidFill>
                   <a:srgbClr val="34D399"/>
                 </a:solidFill>
@@ -14896,7 +14896,7 @@
               <a:t>👉 Zum Ausprobieren reicht </a:t>
             </a:r>
             <a:r>
-              <a:rPr sz="1300" b="1" i="0">
+              <a:rPr sz="1250" b="1" i="0">
                 <a:solidFill>
                   <a:srgbClr val="34D399"/>
                 </a:solidFill>
@@ -14905,13 +14905,35 @@
               <a:t>Free</a:t>
             </a:r>
             <a:r>
-              <a:rPr sz="1300" b="0" i="0">
+              <a:rPr sz="1250" b="0" i="0">
                 <a:solidFill>
                   <a:srgbClr val="9CA8C4"/>
                 </a:solidFill>
                 <a:latin typeface="Segoe UI"/>
               </a:rPr>
-              <a:t> (Social-Login / AWS Builder ID — kein Kreditkarten-Konto nötig). Overage: $0,04 / Credit. Preise: kiro.dev/pricing</a:t>
+              <a:t> (Social-Login / AWS Builder ID — kein Kreditkarten-Konto nötig). Overage: $0,04 / Credit.</a:t>
+            </a:r>
+          </a:p>
+          <a:p>
+            <a:pPr algn="l">
+              <a:lnSpc>
+                <a:spcPct val="105000"/>
+              </a:lnSpc>
+              <a:spcBef>
+                <a:spcPts val="0"/>
+              </a:spcBef>
+              <a:spcAft>
+                <a:spcPts val="400"/>
+              </a:spcAft>
+            </a:pPr>
+            <a:r>
+              <a:rPr sz="1250" b="0" i="0">
+                <a:solidFill>
+                  <a:srgbClr val="FBBF24"/>
+                </a:solidFill>
+                <a:latin typeface="Segoe UI"/>
+              </a:rPr>
+              <a:t>😬 Story: Der Preis-Start 2025 ging schief (Bug zog zu viele Credits ab) → AWS entschuldigte sich, erstattete zurück &amp; baute das Modell neu.</a:t>
             </a:r>
           </a:p>
         </p:txBody>

</xml_diff>

<commit_message>
docs: add verified Kiro pricing-history narrative + hooks accuracy (#2)
From the adversarial /deep-research report (high-confidence, 3-0 verified):
- README/youth doc: tell the Aug 2025 pricing-bug -> apology+refunds ->
  Sep 15 four-tier -> later five-tier (Pro Max) story, with sources.
- README hooks: a hook action is an agent prompt OR a shell command;
  shell hooks don't consume credits. Softened the trigger-event wording
  (a specific expanded event list was refuted in verification).
- README: note model choice affects credit burn (Sonnet-only ~1.3x Auto).
- Deck slide 8: compact pricing-drama note. Regenerated pptx.

Co-authored-by: Claude Opus 4.8 (1M context) <noreply@anthropic.com>
</commit_message>
<xml_diff>
--- a/Kiro_IDE_Orchestrator_2026_Jugend.pptx
+++ b/Kiro_IDE_Orchestrator_2026_Jugend.pptx
@@ -14861,8 +14861,8 @@
         </p:nvSpPr>
         <p:spPr>
           <a:xfrm>
-            <a:off x="640080" y="5989320"/>
-            <a:ext cx="10881360" cy="457200"/>
+            <a:off x="640080" y="5797296"/>
+            <a:ext cx="10881360" cy="822960"/>
           </a:xfrm>
           <a:prstGeom prst="rect">
             <a:avLst/>
@@ -14877,17 +14877,17 @@
           <a:p>
             <a:pPr algn="l">
               <a:lnSpc>
-                <a:spcPct val="100000"/>
-              </a:lnSpc>
-              <a:spcBef>
-                <a:spcPts val="0"/>
-              </a:spcBef>
-              <a:spcAft>
-                <a:spcPts val="600"/>
-              </a:spcAft>
-            </a:pPr>
-            <a:r>
-              <a:rPr sz="1300" b="1" i="0">
+                <a:spcPct val="105000"/>
+              </a:lnSpc>
+              <a:spcBef>
+                <a:spcPts val="0"/>
+              </a:spcBef>
+              <a:spcAft>
+                <a:spcPts val="400"/>
+              </a:spcAft>
+            </a:pPr>
+            <a:r>
+              <a:rPr sz="1250" b="1" i="0">
                 <a:solidFill>
                   <a:srgbClr val="34D399"/>
                 </a:solidFill>
@@ -14896,7 +14896,7 @@
               <a:t>👉 Zum Ausprobieren reicht </a:t>
             </a:r>
             <a:r>
-              <a:rPr sz="1300" b="1" i="0">
+              <a:rPr sz="1250" b="1" i="0">
                 <a:solidFill>
                   <a:srgbClr val="34D399"/>
                 </a:solidFill>
@@ -14905,13 +14905,35 @@
               <a:t>Free</a:t>
             </a:r>
             <a:r>
-              <a:rPr sz="1300" b="0" i="0">
+              <a:rPr sz="1250" b="0" i="0">
                 <a:solidFill>
                   <a:srgbClr val="9CA8C4"/>
                 </a:solidFill>
                 <a:latin typeface="Segoe UI"/>
               </a:rPr>
-              <a:t> (Social-Login / AWS Builder ID — kein Kreditkarten-Konto nötig). Overage: $0,04 / Credit. Preise: kiro.dev/pricing</a:t>
+              <a:t> (Social-Login / AWS Builder ID — kein Kreditkarten-Konto nötig). Overage: $0,04 / Credit.</a:t>
+            </a:r>
+          </a:p>
+          <a:p>
+            <a:pPr algn="l">
+              <a:lnSpc>
+                <a:spcPct val="105000"/>
+              </a:lnSpc>
+              <a:spcBef>
+                <a:spcPts val="0"/>
+              </a:spcBef>
+              <a:spcAft>
+                <a:spcPts val="400"/>
+              </a:spcAft>
+            </a:pPr>
+            <a:r>
+              <a:rPr sz="1250" b="0" i="0">
+                <a:solidFill>
+                  <a:srgbClr val="FBBF24"/>
+                </a:solidFill>
+                <a:latin typeface="Segoe UI"/>
+              </a:rPr>
+              <a:t>😬 Story: Der Preis-Start 2025 ging schief (Bug zog zu viele Credits ab) → AWS entschuldigte sich, erstattete zurück &amp; baute das Modell neu.</a:t>
             </a:r>
           </a:p>
         </p:txBody>

</xml_diff>